<commit_message>
auto: YNG quote actualizado — opción F
</commit_message>
<xml_diff>
--- a/yng-latam-wow.pptx
+++ b/yng-latam-wow.pptx
@@ -11702,8 +11702,7 @@
                 </a:solidFill>
                 <a:latin typeface="Calibri"/>
               </a:rPr>
-              <a:t>No vine a que sean
-la mejor junta de LATAM.</a:t>
+              <a:t>Hoy no hay experto en la sala.</a:t>
             </a:r>
           </a:p>
         </p:txBody>
@@ -11738,7 +11737,7 @@
                 </a:solidFill>
                 <a:latin typeface="Calibri"/>
               </a:rPr>
-              <a:t>Vine a que sean una junta de alto desempeño.</a:t>
+              <a:t>Hay un equipo que va a construir su próximo año.</a:t>
             </a:r>
           </a:p>
         </p:txBody>

</xml_diff>

<commit_message>
auto: YNG PPTX — QR poll insertado
</commit_message>
<xml_diff>
--- a/yng-latam-wow.pptx
+++ b/yng-latam-wow.pptx
@@ -18590,230 +18590,9 @@
           </a:p>
         </p:txBody>
       </p:sp>
-      <p:sp>
-        <p:nvSpPr>
-          <p:cNvPr id="6" name="Rectangle 5"/>
-          <p:cNvSpPr/>
-          <p:nvPr/>
-        </p:nvSpPr>
-        <p:spPr>
-          <a:xfrm>
-            <a:off x="4480560" y="2560320"/>
-            <a:ext cx="3200400" cy="3200400"/>
-          </a:xfrm>
-          <a:prstGeom prst="rect">
-            <a:avLst/>
-          </a:prstGeom>
-          <a:solidFill>
-            <a:srgbClr val="FFFFFF"/>
-          </a:solidFill>
-          <a:ln w="12700">
-            <a:solidFill>
-              <a:srgbClr val="8A9AB0"/>
-            </a:solidFill>
-          </a:ln>
-        </p:spPr>
-        <p:style>
-          <a:lnRef idx="1">
-            <a:schemeClr val="accent1"/>
-          </a:lnRef>
-          <a:fillRef idx="3">
-            <a:schemeClr val="accent1"/>
-          </a:fillRef>
-          <a:effectRef idx="2">
-            <a:schemeClr val="accent1"/>
-          </a:effectRef>
-          <a:fontRef idx="minor">
-            <a:schemeClr val="lt1"/>
-          </a:fontRef>
-        </p:style>
-        <p:txBody>
-          <a:bodyPr rtlCol="0" anchor="ctr"/>
-          <a:lstStyle/>
-          <a:p>
-            <a:pPr algn="ctr"/>
-          </a:p>
-        </p:txBody>
-      </p:sp>
-      <p:sp>
-        <p:nvSpPr>
-          <p:cNvPr id="7" name="TextBox 6"/>
-          <p:cNvSpPr txBox="1"/>
-          <p:nvPr/>
-        </p:nvSpPr>
-        <p:spPr>
-          <a:xfrm>
-            <a:off x="4480560" y="3474720"/>
-            <a:ext cx="3200400" cy="1097280"/>
-          </a:xfrm>
-          <a:prstGeom prst="rect">
-            <a:avLst/>
-          </a:prstGeom>
-          <a:noFill/>
-        </p:spPr>
-        <p:txBody>
-          <a:bodyPr wrap="square">
-            <a:spAutoFit/>
-          </a:bodyPr>
-          <a:lstStyle/>
-          <a:p>
-            <a:pPr algn="ctr"/>
-            <a:r>
-              <a:rPr sz="1400" b="1" i="0">
-                <a:solidFill>
-                  <a:srgbClr val="0A1628"/>
-                </a:solidFill>
-                <a:latin typeface="Calibri"/>
-              </a:rPr>
-              <a:t>QR CODE
-(insertar antes de imprimir)</a:t>
-            </a:r>
-          </a:p>
-        </p:txBody>
-      </p:sp>
-      <p:sp>
-        <p:nvSpPr>
-          <p:cNvPr id="8" name="TextBox 7"/>
-          <p:cNvSpPr txBox="1"/>
-          <p:nvPr/>
-        </p:nvSpPr>
-        <p:spPr>
-          <a:xfrm>
-            <a:off x="2286000" y="5943600"/>
-            <a:ext cx="7589520" cy="457200"/>
-          </a:xfrm>
-          <a:prstGeom prst="rect">
-            <a:avLst/>
-          </a:prstGeom>
-          <a:noFill/>
-        </p:spPr>
-        <p:txBody>
-          <a:bodyPr wrap="square">
-            <a:spAutoFit/>
-          </a:bodyPr>
-          <a:lstStyle/>
-          <a:p>
-            <a:pPr algn="ctr"/>
-            <a:r>
-              <a:rPr sz="900" b="0" i="0">
-                <a:solidFill>
-                  <a:srgbClr val="8A9AB0"/>
-                </a:solidFill>
-                <a:latin typeface="Calibri"/>
-              </a:rPr>
-              <a:t>docs.google.com/forms/d/1FRtR5oFwkuVWiETYiMi5OUA-y38z8-m8RoWyBg8jzCI</a:t>
-            </a:r>
-          </a:p>
-        </p:txBody>
-      </p:sp>
-      <p:sp>
-        <p:nvSpPr>
-          <p:cNvPr id="9" name="TextBox 8"/>
-          <p:cNvSpPr txBox="1"/>
-          <p:nvPr/>
-        </p:nvSpPr>
-        <p:spPr>
-          <a:xfrm>
-            <a:off x="457200" y="2651760"/>
-            <a:ext cx="3840480" cy="594360"/>
-          </a:xfrm>
-          <a:prstGeom prst="rect">
-            <a:avLst/>
-          </a:prstGeom>
-          <a:noFill/>
-        </p:spPr>
-        <p:txBody>
-          <a:bodyPr wrap="square">
-            <a:spAutoFit/>
-          </a:bodyPr>
-          <a:lstStyle/>
-          <a:p>
-            <a:pPr algn="l"/>
-            <a:r>
-              <a:rPr sz="1200" b="0" i="0">
-                <a:solidFill>
-                  <a:srgbClr val="FFFFFF"/>
-                </a:solidFill>
-                <a:latin typeface="Calibri"/>
-              </a:rPr>
-              <a:t>🟢  ¿Qué iniciativas del año pasado deberían continuar?</a:t>
-            </a:r>
-          </a:p>
-        </p:txBody>
-      </p:sp>
-      <p:sp>
-        <p:nvSpPr>
-          <p:cNvPr id="10" name="TextBox 9"/>
-          <p:cNvSpPr txBox="1"/>
-          <p:nvPr/>
-        </p:nvSpPr>
-        <p:spPr>
-          <a:xfrm>
-            <a:off x="457200" y="3337560"/>
-            <a:ext cx="3840480" cy="594360"/>
-          </a:xfrm>
-          <a:prstGeom prst="rect">
-            <a:avLst/>
-          </a:prstGeom>
-          <a:noFill/>
-        </p:spPr>
-        <p:txBody>
-          <a:bodyPr wrap="square">
-            <a:spAutoFit/>
-          </a:bodyPr>
-          <a:lstStyle/>
-          <a:p>
-            <a:pPr algn="l"/>
-            <a:r>
-              <a:rPr sz="1200" b="0" i="0">
-                <a:solidFill>
-                  <a:srgbClr val="FFFFFF"/>
-                </a:solidFill>
-                <a:latin typeface="Calibri"/>
-              </a:rPr>
-              <a:t>🔴  ¿Qué dejamos de hacer o necesita cambiar?</a:t>
-            </a:r>
-          </a:p>
-        </p:txBody>
-      </p:sp>
-      <p:sp>
-        <p:nvSpPr>
-          <p:cNvPr id="11" name="TextBox 10"/>
-          <p:cNvSpPr txBox="1"/>
-          <p:nvPr/>
-        </p:nvSpPr>
-        <p:spPr>
-          <a:xfrm>
-            <a:off x="457200" y="4023360"/>
-            <a:ext cx="3840480" cy="594360"/>
-          </a:xfrm>
-          <a:prstGeom prst="rect">
-            <a:avLst/>
-          </a:prstGeom>
-          <a:noFill/>
-        </p:spPr>
-        <p:txBody>
-          <a:bodyPr wrap="square">
-            <a:spAutoFit/>
-          </a:bodyPr>
-          <a:lstStyle/>
-          <a:p>
-            <a:pPr algn="l"/>
-            <a:r>
-              <a:rPr sz="1200" b="0" i="0">
-                <a:solidFill>
-                  <a:srgbClr val="FFFFFF"/>
-                </a:solidFill>
-                <a:latin typeface="Calibri"/>
-              </a:rPr>
-              <a:t>💡  ¿Qué nunca hemos hecho y deberíamos intentar este año?</a:t>
-            </a:r>
-          </a:p>
-        </p:txBody>
-      </p:sp>
       <p:pic>
         <p:nvPicPr>
-          <p:cNvPr id="12" name="Picture 11" descr="yng_logo.png"/>
+          <p:cNvPr id="6" name="Picture 5" descr="yng_qr_poll.png"/>
           <p:cNvPicPr>
             <a:picLocks noChangeAspect="1"/>
           </p:cNvPicPr>
@@ -18821,6 +18600,170 @@
         </p:nvPicPr>
         <p:blipFill>
           <a:blip r:embed="rId2"/>
+          <a:stretch>
+            <a:fillRect/>
+          </a:stretch>
+        </p:blipFill>
+        <p:spPr>
+          <a:xfrm>
+            <a:off x="4480560" y="2468880"/>
+            <a:ext cx="3200400" cy="3200400"/>
+          </a:xfrm>
+          <a:prstGeom prst="rect">
+            <a:avLst/>
+          </a:prstGeom>
+        </p:spPr>
+      </p:pic>
+      <p:sp>
+        <p:nvSpPr>
+          <p:cNvPr id="7" name="TextBox 6"/>
+          <p:cNvSpPr txBox="1"/>
+          <p:nvPr/>
+        </p:nvSpPr>
+        <p:spPr>
+          <a:xfrm>
+            <a:off x="2286000" y="5852160"/>
+            <a:ext cx="7589520" cy="457200"/>
+          </a:xfrm>
+          <a:prstGeom prst="rect">
+            <a:avLst/>
+          </a:prstGeom>
+          <a:noFill/>
+        </p:spPr>
+        <p:txBody>
+          <a:bodyPr wrap="square">
+            <a:spAutoFit/>
+          </a:bodyPr>
+          <a:lstStyle/>
+          <a:p>
+            <a:pPr algn="ctr"/>
+            <a:r>
+              <a:rPr sz="900" b="0" i="0">
+                <a:solidFill>
+                  <a:srgbClr val="8A9AB0"/>
+                </a:solidFill>
+                <a:latin typeface="Calibri"/>
+              </a:rPr>
+              <a:t>forms.gle · YNG LATAM Board Feedback 2026</a:t>
+            </a:r>
+          </a:p>
+        </p:txBody>
+      </p:sp>
+      <p:sp>
+        <p:nvSpPr>
+          <p:cNvPr id="8" name="TextBox 7"/>
+          <p:cNvSpPr txBox="1"/>
+          <p:nvPr/>
+        </p:nvSpPr>
+        <p:spPr>
+          <a:xfrm>
+            <a:off x="457200" y="2651760"/>
+            <a:ext cx="3840480" cy="594360"/>
+          </a:xfrm>
+          <a:prstGeom prst="rect">
+            <a:avLst/>
+          </a:prstGeom>
+          <a:noFill/>
+        </p:spPr>
+        <p:txBody>
+          <a:bodyPr wrap="square">
+            <a:spAutoFit/>
+          </a:bodyPr>
+          <a:lstStyle/>
+          <a:p>
+            <a:pPr algn="l"/>
+            <a:r>
+              <a:rPr sz="1200" b="0" i="0">
+                <a:solidFill>
+                  <a:srgbClr val="FFFFFF"/>
+                </a:solidFill>
+                <a:latin typeface="Calibri"/>
+              </a:rPr>
+              <a:t>🟢  ¿Qué iniciativas del año pasado deberían continuar?</a:t>
+            </a:r>
+          </a:p>
+        </p:txBody>
+      </p:sp>
+      <p:sp>
+        <p:nvSpPr>
+          <p:cNvPr id="9" name="TextBox 8"/>
+          <p:cNvSpPr txBox="1"/>
+          <p:nvPr/>
+        </p:nvSpPr>
+        <p:spPr>
+          <a:xfrm>
+            <a:off x="457200" y="3337560"/>
+            <a:ext cx="3840480" cy="594360"/>
+          </a:xfrm>
+          <a:prstGeom prst="rect">
+            <a:avLst/>
+          </a:prstGeom>
+          <a:noFill/>
+        </p:spPr>
+        <p:txBody>
+          <a:bodyPr wrap="square">
+            <a:spAutoFit/>
+          </a:bodyPr>
+          <a:lstStyle/>
+          <a:p>
+            <a:pPr algn="l"/>
+            <a:r>
+              <a:rPr sz="1200" b="0" i="0">
+                <a:solidFill>
+                  <a:srgbClr val="FFFFFF"/>
+                </a:solidFill>
+                <a:latin typeface="Calibri"/>
+              </a:rPr>
+              <a:t>🔴  ¿Qué dejamos de hacer o necesita cambiar?</a:t>
+            </a:r>
+          </a:p>
+        </p:txBody>
+      </p:sp>
+      <p:sp>
+        <p:nvSpPr>
+          <p:cNvPr id="10" name="TextBox 9"/>
+          <p:cNvSpPr txBox="1"/>
+          <p:nvPr/>
+        </p:nvSpPr>
+        <p:spPr>
+          <a:xfrm>
+            <a:off x="457200" y="4023360"/>
+            <a:ext cx="3840480" cy="594360"/>
+          </a:xfrm>
+          <a:prstGeom prst="rect">
+            <a:avLst/>
+          </a:prstGeom>
+          <a:noFill/>
+        </p:spPr>
+        <p:txBody>
+          <a:bodyPr wrap="square">
+            <a:spAutoFit/>
+          </a:bodyPr>
+          <a:lstStyle/>
+          <a:p>
+            <a:pPr algn="l"/>
+            <a:r>
+              <a:rPr sz="1200" b="0" i="0">
+                <a:solidFill>
+                  <a:srgbClr val="FFFFFF"/>
+                </a:solidFill>
+                <a:latin typeface="Calibri"/>
+              </a:rPr>
+              <a:t>💡  ¿Qué nunca hemos hecho y deberíamos intentar este año?</a:t>
+            </a:r>
+          </a:p>
+        </p:txBody>
+      </p:sp>
+      <p:pic>
+        <p:nvPicPr>
+          <p:cNvPr id="11" name="Picture 10" descr="yng_logo.png"/>
+          <p:cNvPicPr>
+            <a:picLocks noChangeAspect="1"/>
+          </p:cNvPicPr>
+          <p:nvPr/>
+        </p:nvPicPr>
+        <p:blipFill>
+          <a:blip r:embed="rId3"/>
           <a:stretch>
             <a:fillRect/>
           </a:stretch>

</xml_diff>

<commit_message>
auto: YNG — fecha corregida a 13 junio 2026 (HTML + PPTX)
</commit_message>
<xml_diff>
--- a/yng-latam-wow.pptx
+++ b/yng-latam-wow.pptx
@@ -3336,7 +3336,7 @@
                 </a:solidFill>
                 <a:latin typeface="Calibri"/>
               </a:rPr>
-              <a:t>Bogotá, 14 junio 2026  ·  09:00 – 14:15</a:t>
+              <a:t>Bogotá, 13 junio 2026  ·  09:00 – 14:15</a:t>
             </a:r>
           </a:p>
         </p:txBody>
@@ -15826,7 +15826,7 @@
                 </a:solidFill>
                 <a:latin typeface="Calibri"/>
               </a:rPr>
-              <a:t>AGENDA · BOGOTÁ · 14 JUNIO 2026</a:t>
+              <a:t>AGENDA · BOGOTÁ · 13 JUNIO 2026</a:t>
             </a:r>
           </a:p>
         </p:txBody>

</xml_diff>

<commit_message>
auto: YNG — quote B actualizado en PPTX + HTML
</commit_message>
<xml_diff>
--- a/yng-latam-wow.pptx
+++ b/yng-latam-wow.pptx
@@ -13231,7 +13231,7 @@
                 </a:solidFill>
                 <a:latin typeface="Calibri"/>
               </a:rPr>
-              <a:t>Hoy no hay experto en la sala.</a:t>
+              <a:t>El plan no cambia nada.</a:t>
             </a:r>
           </a:p>
         </p:txBody>
@@ -13266,7 +13266,7 @@
                 </a:solidFill>
                 <a:latin typeface="Calibri"/>
               </a:rPr>
-              <a:t>Hay un equipo que va a construir su próximo año.</a:t>
+              <a:t>Las personas que lo viven con convicción, sí.</a:t>
             </a:r>
           </a:p>
         </p:txBody>
@@ -14354,8 +14354,8 @@
                 </a:solidFill>
                 <a:latin typeface="Calibri"/>
               </a:rPr>
-              <a:t>"Hoy no hay experto en la sala.
-Hay un equipo que va a construir su próximo año."</a:t>
+              <a:t>"El plan no cambia nada.
+Las personas que lo viven con convicción, sí."</a:t>
             </a:r>
           </a:p>
         </p:txBody>

</xml_diff>